<commit_message>
Clean up poster code
</commit_message>
<xml_diff>
--- a/pci_poster/poster_template.pptx
+++ b/pci_poster/poster_template.pptx
@@ -732,7 +732,7 @@
           <a:p>
             <a:fld id="{71C53CA5-41C7-4923-8C6F-B3E91010339F}" type="datetimeFigureOut">
               <a:rPr lang="en-AU" smtClean="0"/>
-              <a:t>21/08/2026</a:t>
+              <a:t>16/10/2026</a:t>
             </a:fld>
             <a:endParaRPr lang="en-AU"/>
           </a:p>
@@ -909,7 +909,7 @@
           <a:p>
             <a:fld id="{C000ED89-5811-46A2-AFCA-7C8C83CE9906}" type="datetimeFigureOut">
               <a:rPr lang="en-AU" smtClean="0"/>
-              <a:t>21/08/2026</a:t>
+              <a:t>16/10/2026</a:t>
             </a:fld>
             <a:endParaRPr lang="en-AU"/>
           </a:p>
@@ -1265,7 +1265,7 @@
       </p:sp>
       <p:sp>
         <p:nvSpPr>
-          <p:cNvPr id="38" name="ph_disch_meds_dapt">
+          <p:cNvPr id="38" name="ph_NCR11_desc">
             <a:extLst>
               <a:ext uri="{FF2B5EF4-FFF2-40B4-BE49-F238E27FC236}">
                 <a16:creationId xmlns:a16="http://schemas.microsoft.com/office/drawing/2014/main" id="{D56FA25C-826C-AEF5-957C-F09DBE615CC2}"/>
@@ -1307,7 +1307,7 @@
       </p:sp>
       <p:sp>
         <p:nvSpPr>
-          <p:cNvPr id="49" name="ph_disch_meds_dapt_pct">
+          <p:cNvPr id="49" name="ph_NCR11_value">
             <a:extLst>
               <a:ext uri="{FF2B5EF4-FFF2-40B4-BE49-F238E27FC236}">
                 <a16:creationId xmlns:a16="http://schemas.microsoft.com/office/drawing/2014/main" id="{1FE6F18A-7157-4F0B-5E13-82B5E30007F4}"/>
@@ -1382,7 +1382,7 @@
       </p:sp>
       <p:grpSp>
         <p:nvGrpSpPr>
-          <p:cNvPr id="4" name="meds">
+          <p:cNvPr id="4" name="grp_NCR11">
             <a:extLst>
               <a:ext uri="{FF2B5EF4-FFF2-40B4-BE49-F238E27FC236}">
                 <a16:creationId xmlns:a16="http://schemas.microsoft.com/office/drawing/2014/main" id="{99DC304C-9316-ACD0-00ED-67563F615699}"/>
@@ -1402,7 +1402,7 @@
         </p:grpSpPr>
         <p:sp>
           <p:nvSpPr>
-            <p:cNvPr id="21" name="shp_meds">
+            <p:cNvPr id="21" name="shp_NCR11">
               <a:extLst>
                 <a:ext uri="{FF2B5EF4-FFF2-40B4-BE49-F238E27FC236}">
                   <a16:creationId xmlns:a16="http://schemas.microsoft.com/office/drawing/2014/main" id="{8E7B100D-340E-CDEA-8F6B-7FDE741C252A}"/>
@@ -1458,7 +1458,7 @@
         </p:sp>
         <p:pic>
           <p:nvPicPr>
-            <p:cNvPr id="2075" name="pic_meds" descr="Pill - Free healthcare and medical icons">
+            <p:cNvPr id="2075" name="pic_NCR11" descr="Pill - Free healthcare and medical icons">
               <a:extLst>
                 <a:ext uri="{FF2B5EF4-FFF2-40B4-BE49-F238E27FC236}">
                   <a16:creationId xmlns:a16="http://schemas.microsoft.com/office/drawing/2014/main" id="{541A6AC7-D175-3548-67FC-DC5600EFAB59}"/>
@@ -1506,7 +1506,54 @@
       </p:grpSp>
       <p:sp>
         <p:nvSpPr>
-          <p:cNvPr id="48" name="ph_radial_pct">
+          <p:cNvPr id="37" name="ph_Q2100_desc">
+            <a:extLst>
+              <a:ext uri="{FF2B5EF4-FFF2-40B4-BE49-F238E27FC236}">
+                <a16:creationId xmlns:a16="http://schemas.microsoft.com/office/drawing/2014/main" id="{814A0012-CF31-67AE-4E97-AA42CBE2A6AE}"/>
+              </a:ext>
+            </a:extLst>
+          </p:cNvPr>
+          <p:cNvSpPr>
+            <a:spLocks noGrp="1"/>
+          </p:cNvSpPr>
+          <p:nvPr>
+            <p:ph type="body" sz="quarter" idx="12" hasCustomPrompt="1"/>
+          </p:nvPr>
+        </p:nvSpPr>
+        <p:spPr>
+          <a:xfrm>
+            <a:off x="4986852" y="5774838"/>
+            <a:ext cx="1839649" cy="620712"/>
+          </a:xfrm>
+          <a:prstGeom prst="rect">
+            <a:avLst/>
+          </a:prstGeom>
+        </p:spPr>
+        <p:txBody>
+          <a:bodyPr lIns="0" tIns="0" rIns="0" bIns="0"/>
+          <a:lstStyle>
+            <a:lvl1pPr marL="0" indent="0">
+              <a:buNone/>
+              <a:defRPr sz="1600"/>
+            </a:lvl1pPr>
+          </a:lstStyle>
+          <a:p>
+            <a:pPr lvl="0"/>
+            <a:r>
+              <a:rPr lang="en-AU" dirty="0"/>
+              <a:t>X of Y </a:t>
+            </a:r>
+            <a:r>
+              <a:rPr lang="en-GB" dirty="0"/>
+              <a:t>PCI were performed via Radial Access</a:t>
+            </a:r>
+            <a:endParaRPr lang="en-AU" dirty="0"/>
+          </a:p>
+        </p:txBody>
+      </p:sp>
+      <p:sp>
+        <p:nvSpPr>
+          <p:cNvPr id="48" name="ph_Q2100_value">
             <a:extLst>
               <a:ext uri="{FF2B5EF4-FFF2-40B4-BE49-F238E27FC236}">
                 <a16:creationId xmlns:a16="http://schemas.microsoft.com/office/drawing/2014/main" id="{7BD5F46B-2231-6D01-C514-F696C7DDE546}"/>
@@ -1578,12 +1625,161 @@
           </a:p>
         </p:txBody>
       </p:sp>
+      <p:grpSp>
+        <p:nvGrpSpPr>
+          <p:cNvPr id="2" name="grp_Q2100">
+            <a:extLst>
+              <a:ext uri="{FF2B5EF4-FFF2-40B4-BE49-F238E27FC236}">
+                <a16:creationId xmlns:a16="http://schemas.microsoft.com/office/drawing/2014/main" id="{B5E3AA50-0418-452B-C37C-6A5EE4384741}"/>
+              </a:ext>
+            </a:extLst>
+          </p:cNvPr>
+          <p:cNvGrpSpPr/>
+          <p:nvPr userDrawn="1"/>
+        </p:nvGrpSpPr>
+        <p:grpSpPr>
+          <a:xfrm>
+            <a:off x="4721340" y="4301898"/>
+            <a:ext cx="900000" cy="900000"/>
+            <a:chOff x="4622484" y="4969171"/>
+            <a:chExt cx="900000" cy="900000"/>
+          </a:xfrm>
+        </p:grpSpPr>
+        <p:sp>
+          <p:nvSpPr>
+            <p:cNvPr id="18" name="shp_Q2100">
+              <a:extLst>
+                <a:ext uri="{FF2B5EF4-FFF2-40B4-BE49-F238E27FC236}">
+                  <a16:creationId xmlns:a16="http://schemas.microsoft.com/office/drawing/2014/main" id="{F398ED92-E238-6D9E-B3F0-984D6E2E8650}"/>
+                </a:ext>
+              </a:extLst>
+            </p:cNvPr>
+            <p:cNvSpPr/>
+            <p:nvPr userDrawn="1"/>
+          </p:nvSpPr>
+          <p:spPr>
+            <a:xfrm>
+              <a:off x="4622484" y="4969171"/>
+              <a:ext cx="900000" cy="900000"/>
+            </a:xfrm>
+            <a:prstGeom prst="ellipse">
+              <a:avLst/>
+            </a:prstGeom>
+            <a:solidFill>
+              <a:schemeClr val="accent5">
+                <a:lumMod val="60000"/>
+                <a:lumOff val="40000"/>
+              </a:schemeClr>
+            </a:solidFill>
+            <a:ln>
+              <a:noFill/>
+            </a:ln>
+          </p:spPr>
+          <p:style>
+            <a:lnRef idx="2">
+              <a:schemeClr val="accent1">
+                <a:shade val="50000"/>
+              </a:schemeClr>
+            </a:lnRef>
+            <a:fillRef idx="1">
+              <a:schemeClr val="accent1"/>
+            </a:fillRef>
+            <a:effectRef idx="0">
+              <a:schemeClr val="accent1"/>
+            </a:effectRef>
+            <a:fontRef idx="minor">
+              <a:schemeClr val="lt1"/>
+            </a:fontRef>
+          </p:style>
+          <p:txBody>
+            <a:bodyPr rtlCol="0" anchor="ctr"/>
+            <a:lstStyle/>
+            <a:p>
+              <a:pPr algn="ctr"/>
+              <a:endParaRPr lang="en-AU" sz="1801" dirty="0">
+                <a:solidFill>
+                  <a:schemeClr val="accent1"/>
+                </a:solidFill>
+              </a:endParaRPr>
+            </a:p>
+          </p:txBody>
+        </p:sp>
+        <p:pic>
+          <p:nvPicPr>
+            <p:cNvPr id="12" name="pic_Q2100">
+              <a:extLst>
+                <a:ext uri="{FF2B5EF4-FFF2-40B4-BE49-F238E27FC236}">
+                  <a16:creationId xmlns:a16="http://schemas.microsoft.com/office/drawing/2014/main" id="{4A335C9F-C929-90C4-EE54-C3B0862F27AB}"/>
+                </a:ext>
+              </a:extLst>
+            </p:cNvPr>
+            <p:cNvPicPr>
+              <a:picLocks noChangeAspect="1"/>
+            </p:cNvPicPr>
+            <p:nvPr userDrawn="1"/>
+          </p:nvPicPr>
+          <p:blipFill>
+            <a:blip r:embed="rId4">
+              <a:clrChange>
+                <a:clrFrom>
+                  <a:srgbClr val="000000"/>
+                </a:clrFrom>
+                <a:clrTo>
+                  <a:srgbClr val="000000">
+                    <a:alpha val="0"/>
+                  </a:srgbClr>
+                </a:clrTo>
+              </a:clrChange>
+              <a:extLst>
+                <a:ext uri="{BEBA8EAE-BF5A-486C-A8C5-ECC9F3942E4B}">
+                  <a14:imgProps xmlns:a14="http://schemas.microsoft.com/office/drawing/2010/main">
+                    <a14:imgLayer r:embed="rId5">
+                      <a14:imgEffect>
+                        <a14:backgroundRemoval t="10000" b="90000" l="10000" r="90000">
+                          <a14:foregroundMark x1="42383" y1="45117" x2="42383" y2="45117"/>
+                          <a14:foregroundMark x1="44141" y1="45605" x2="44141" y2="45605"/>
+                          <a14:foregroundMark x1="46777" y1="45703" x2="46777" y2="45703"/>
+                          <a14:foregroundMark x1="52734" y1="45996" x2="52734" y2="45996"/>
+                          <a14:foregroundMark x1="54492" y1="45996" x2="54492" y2="45996"/>
+                          <a14:foregroundMark x1="49805" y1="49121" x2="49805" y2="49121"/>
+                          <a14:foregroundMark x1="56738" y1="45605" x2="56738" y2="45605"/>
+                          <a14:foregroundMark x1="58887" y1="45996" x2="58887" y2="45996"/>
+                          <a14:foregroundMark x1="60547" y1="45801" x2="60547" y2="45801"/>
+                          <a14:foregroundMark x1="62988" y1="45996" x2="62988" y2="45996"/>
+                          <a14:foregroundMark x1="65723" y1="46191" x2="65723" y2="46191"/>
+                          <a14:foregroundMark x1="67188" y1="46191" x2="67188" y2="46191"/>
+                          <a14:foregroundMark x1="69336" y1="46094" x2="69336" y2="46094"/>
+                          <a14:foregroundMark x1="71875" y1="45996" x2="71875" y2="45996"/>
+                          <a14:foregroundMark x1="73730" y1="46582" x2="73730" y2="46582"/>
+                          <a14:foregroundMark x1="75684" y1="46777" x2="75684" y2="46777"/>
+                          <a14:foregroundMark x1="77637" y1="47656" x2="77637" y2="47656"/>
+                        </a14:backgroundRemoval>
+                      </a14:imgEffect>
+                    </a14:imgLayer>
+                  </a14:imgProps>
+                </a:ext>
+              </a:extLst>
+            </a:blip>
+            <a:srcRect l="9320" t="28301" r="45829" b="33282"/>
+            <a:stretch/>
+          </p:blipFill>
+          <p:spPr>
+            <a:xfrm rot="1623292">
+              <a:off x="4663014" y="5011030"/>
+              <a:ext cx="848642" cy="726915"/>
+            </a:xfrm>
+            <a:prstGeom prst="rect">
+              <a:avLst/>
+            </a:prstGeom>
+          </p:spPr>
+        </p:pic>
+      </p:grpSp>
       <p:sp>
         <p:nvSpPr>
-          <p:cNvPr id="37" name="ph_radial">
+          <p:cNvPr id="41" name="ph_Q2101_desc">
             <a:extLst>
               <a:ext uri="{FF2B5EF4-FFF2-40B4-BE49-F238E27FC236}">
-                <a16:creationId xmlns:a16="http://schemas.microsoft.com/office/drawing/2014/main" id="{814A0012-CF31-67AE-4E97-AA42CBE2A6AE}"/>
+                <a16:creationId xmlns:a16="http://schemas.microsoft.com/office/drawing/2014/main" id="{D4F00C51-9060-7169-179B-F541DAFC0C7E}"/>
               </a:ext>
             </a:extLst>
           </p:cNvPr>
@@ -1591,13 +1787,13 @@
             <a:spLocks noGrp="1"/>
           </p:cNvSpPr>
           <p:nvPr>
-            <p:ph type="body" sz="quarter" idx="12" hasCustomPrompt="1"/>
+            <p:ph type="body" sz="quarter" idx="15" hasCustomPrompt="1"/>
           </p:nvPr>
         </p:nvSpPr>
         <p:spPr>
           <a:xfrm>
-            <a:off x="4986852" y="5774838"/>
-            <a:ext cx="1839649" cy="620712"/>
+            <a:off x="4266801" y="3585199"/>
+            <a:ext cx="2500255" cy="610343"/>
           </a:xfrm>
           <a:prstGeom prst="rect">
             <a:avLst/>
@@ -1606,7 +1802,7 @@
         <p:txBody>
           <a:bodyPr lIns="0" tIns="0" rIns="0" bIns="0"/>
           <a:lstStyle>
-            <a:lvl1pPr marL="0" indent="0">
+            <a:lvl1pPr marL="0" indent="0" algn="l">
               <a:buNone/>
               <a:defRPr sz="1600"/>
             </a:lvl1pPr>
@@ -1615,19 +1811,524 @@
             <a:pPr lvl="0"/>
             <a:r>
               <a:rPr lang="en-AU" dirty="0"/>
-              <a:t>X of Y </a:t>
+              <a:t>X of Y PCI were emergencies for STEMI</a:t>
             </a:r>
+          </a:p>
+        </p:txBody>
+      </p:sp>
+      <p:sp>
+        <p:nvSpPr>
+          <p:cNvPr id="47" name="ph_Q2101_value">
+            <a:extLst>
+              <a:ext uri="{FF2B5EF4-FFF2-40B4-BE49-F238E27FC236}">
+                <a16:creationId xmlns:a16="http://schemas.microsoft.com/office/drawing/2014/main" id="{B1F62D07-2195-698B-2714-154E4501E4EB}"/>
+              </a:ext>
+            </a:extLst>
+          </p:cNvPr>
+          <p:cNvSpPr>
+            <a:spLocks noGrp="1"/>
+          </p:cNvSpPr>
+          <p:nvPr>
+            <p:ph type="body" sz="quarter" idx="27" hasCustomPrompt="1"/>
+          </p:nvPr>
+        </p:nvSpPr>
+        <p:spPr>
+          <a:xfrm>
+            <a:off x="5019163" y="2792147"/>
+            <a:ext cx="1516977" cy="504000"/>
+          </a:xfrm>
+          <a:prstGeom prst="rect">
+            <a:avLst/>
+          </a:prstGeom>
+        </p:spPr>
+        <p:txBody>
+          <a:bodyPr lIns="0" tIns="0" rIns="0" bIns="0" anchor="ctr" anchorCtr="0"/>
+          <a:lstStyle>
+            <a:lvl1pPr marL="0" indent="0" algn="l">
+              <a:buNone/>
+              <a:defRPr sz="4800">
+                <a:solidFill>
+                  <a:srgbClr val="133F6D"/>
+                </a:solidFill>
+              </a:defRPr>
+            </a:lvl1pPr>
+            <a:lvl2pPr>
+              <a:defRPr>
+                <a:solidFill>
+                  <a:srgbClr val="133F6D"/>
+                </a:solidFill>
+              </a:defRPr>
+            </a:lvl2pPr>
+            <a:lvl3pPr>
+              <a:defRPr>
+                <a:solidFill>
+                  <a:srgbClr val="133F6D"/>
+                </a:solidFill>
+              </a:defRPr>
+            </a:lvl3pPr>
+            <a:lvl4pPr>
+              <a:defRPr>
+                <a:solidFill>
+                  <a:srgbClr val="133F6D"/>
+                </a:solidFill>
+              </a:defRPr>
+            </a:lvl4pPr>
+            <a:lvl5pPr>
+              <a:defRPr>
+                <a:solidFill>
+                  <a:srgbClr val="133F6D"/>
+                </a:solidFill>
+              </a:defRPr>
+            </a:lvl5pPr>
+          </a:lstStyle>
+          <a:p>
+            <a:pPr lvl="0"/>
             <a:r>
-              <a:rPr lang="en-GB" dirty="0"/>
-              <a:t>PCI were performed via Radial Access</a:t>
+              <a:rPr lang="en-US" dirty="0"/>
+              <a:t>X%</a:t>
             </a:r>
             <a:endParaRPr lang="en-AU" dirty="0"/>
           </a:p>
         </p:txBody>
       </p:sp>
+      <p:grpSp>
+        <p:nvGrpSpPr>
+          <p:cNvPr id="8" name="grp_Q2101">
+            <a:extLst>
+              <a:ext uri="{FF2B5EF4-FFF2-40B4-BE49-F238E27FC236}">
+                <a16:creationId xmlns:a16="http://schemas.microsoft.com/office/drawing/2014/main" id="{48F6A469-26C0-EA12-0433-BAE178F0D17F}"/>
+              </a:ext>
+            </a:extLst>
+          </p:cNvPr>
+          <p:cNvGrpSpPr/>
+          <p:nvPr userDrawn="1"/>
+        </p:nvGrpSpPr>
+        <p:grpSpPr>
+          <a:xfrm>
+            <a:off x="3804989" y="2399161"/>
+            <a:ext cx="1138003" cy="1138003"/>
+            <a:chOff x="3804989" y="2621587"/>
+            <a:chExt cx="1138003" cy="1138003"/>
+          </a:xfrm>
+        </p:grpSpPr>
+        <p:sp>
+          <p:nvSpPr>
+            <p:cNvPr id="22" name="shp_Q2101">
+              <a:extLst>
+                <a:ext uri="{FF2B5EF4-FFF2-40B4-BE49-F238E27FC236}">
+                  <a16:creationId xmlns:a16="http://schemas.microsoft.com/office/drawing/2014/main" id="{A79E2BBB-6172-9A7B-B7D2-88173061667A}"/>
+                </a:ext>
+              </a:extLst>
+            </p:cNvPr>
+            <p:cNvSpPr/>
+            <p:nvPr userDrawn="1"/>
+          </p:nvSpPr>
+          <p:spPr>
+            <a:xfrm>
+              <a:off x="3911092" y="2786713"/>
+              <a:ext cx="900000" cy="900000"/>
+            </a:xfrm>
+            <a:prstGeom prst="ellipse">
+              <a:avLst/>
+            </a:prstGeom>
+            <a:solidFill>
+              <a:schemeClr val="accent1"/>
+            </a:solidFill>
+            <a:ln>
+              <a:noFill/>
+            </a:ln>
+          </p:spPr>
+          <p:style>
+            <a:lnRef idx="2">
+              <a:schemeClr val="accent1">
+                <a:shade val="50000"/>
+              </a:schemeClr>
+            </a:lnRef>
+            <a:fillRef idx="1">
+              <a:schemeClr val="accent1"/>
+            </a:fillRef>
+            <a:effectRef idx="0">
+              <a:schemeClr val="accent1"/>
+            </a:effectRef>
+            <a:fontRef idx="minor">
+              <a:schemeClr val="lt1"/>
+            </a:fontRef>
+          </p:style>
+          <p:txBody>
+            <a:bodyPr rtlCol="0" anchor="ctr"/>
+            <a:lstStyle/>
+            <a:p>
+              <a:pPr algn="ctr"/>
+              <a:endParaRPr lang="en-AU" sz="1801" dirty="0">
+                <a:solidFill>
+                  <a:schemeClr val="accent1"/>
+                </a:solidFill>
+              </a:endParaRPr>
+            </a:p>
+          </p:txBody>
+        </p:sp>
+        <p:pic>
+          <p:nvPicPr>
+            <p:cNvPr id="24" name="pic_Q2101">
+              <a:extLst>
+                <a:ext uri="{FF2B5EF4-FFF2-40B4-BE49-F238E27FC236}">
+                  <a16:creationId xmlns:a16="http://schemas.microsoft.com/office/drawing/2014/main" id="{C4803C3E-DE7F-2182-D796-F9D9BADE5615}"/>
+                </a:ext>
+              </a:extLst>
+            </p:cNvPr>
+            <p:cNvPicPr>
+              <a:picLocks noChangeAspect="1"/>
+            </p:cNvPicPr>
+            <p:nvPr userDrawn="1"/>
+          </p:nvPicPr>
+          <p:blipFill>
+            <a:blip r:embed="rId6"/>
+            <a:stretch>
+              <a:fillRect/>
+            </a:stretch>
+          </p:blipFill>
+          <p:spPr>
+            <a:xfrm>
+              <a:off x="3804989" y="2621587"/>
+              <a:ext cx="1138003" cy="1138003"/>
+            </a:xfrm>
+            <a:prstGeom prst="rect">
+              <a:avLst/>
+            </a:prstGeom>
+          </p:spPr>
+        </p:pic>
+      </p:grpSp>
       <p:sp>
         <p:nvSpPr>
-          <p:cNvPr id="5" name="mins">
+          <p:cNvPr id="42" name="ph_NCR10_desc">
+            <a:extLst>
+              <a:ext uri="{FF2B5EF4-FFF2-40B4-BE49-F238E27FC236}">
+                <a16:creationId xmlns:a16="http://schemas.microsoft.com/office/drawing/2014/main" id="{EF9CBF36-A38B-ED1E-AFAF-CEAD51735C04}"/>
+              </a:ext>
+            </a:extLst>
+          </p:cNvPr>
+          <p:cNvSpPr>
+            <a:spLocks noGrp="1"/>
+          </p:cNvSpPr>
+          <p:nvPr>
+            <p:ph type="body" sz="quarter" idx="14" hasCustomPrompt="1"/>
+          </p:nvPr>
+        </p:nvSpPr>
+        <p:spPr>
+          <a:xfrm>
+            <a:off x="369771" y="7791190"/>
+            <a:ext cx="2630768" cy="823559"/>
+          </a:xfrm>
+          <a:prstGeom prst="rect">
+            <a:avLst/>
+          </a:prstGeom>
+        </p:spPr>
+        <p:txBody>
+          <a:bodyPr lIns="0" tIns="0" rIns="0" bIns="0"/>
+          <a:lstStyle>
+            <a:lvl1pPr marL="0" indent="0" algn="r">
+              <a:buNone/>
+              <a:defRPr sz="1600"/>
+            </a:lvl1pPr>
+          </a:lstStyle>
+          <a:p>
+            <a:pPr lvl="0"/>
+            <a:r>
+              <a:rPr lang="en-GB" dirty="0"/>
+              <a:t>Evidence of referral to Cardiac Rehab was available in </a:t>
+            </a:r>
+            <a:r>
+              <a:rPr lang="en-AU" dirty="0"/>
+              <a:t>X out of Y patients</a:t>
+            </a:r>
+          </a:p>
+        </p:txBody>
+      </p:sp>
+      <p:sp>
+        <p:nvSpPr>
+          <p:cNvPr id="50" name="ph_NCR10_value">
+            <a:extLst>
+              <a:ext uri="{FF2B5EF4-FFF2-40B4-BE49-F238E27FC236}">
+                <a16:creationId xmlns:a16="http://schemas.microsoft.com/office/drawing/2014/main" id="{A8C0D454-B653-61F4-5751-F6813F0ADF7C}"/>
+              </a:ext>
+            </a:extLst>
+          </p:cNvPr>
+          <p:cNvSpPr>
+            <a:spLocks noGrp="1"/>
+          </p:cNvSpPr>
+          <p:nvPr>
+            <p:ph type="body" sz="quarter" idx="30" hasCustomPrompt="1"/>
+          </p:nvPr>
+        </p:nvSpPr>
+        <p:spPr>
+          <a:xfrm>
+            <a:off x="461442" y="6935565"/>
+            <a:ext cx="1548000" cy="504000"/>
+          </a:xfrm>
+          <a:prstGeom prst="rect">
+            <a:avLst/>
+          </a:prstGeom>
+        </p:spPr>
+        <p:txBody>
+          <a:bodyPr lIns="0" tIns="0" rIns="0" bIns="0" anchor="ctr" anchorCtr="0"/>
+          <a:lstStyle>
+            <a:lvl1pPr marL="0" indent="0" algn="r">
+              <a:buNone/>
+              <a:defRPr sz="4800">
+                <a:solidFill>
+                  <a:srgbClr val="FFC000"/>
+                </a:solidFill>
+              </a:defRPr>
+            </a:lvl1pPr>
+            <a:lvl2pPr>
+              <a:defRPr>
+                <a:solidFill>
+                  <a:srgbClr val="FFC000"/>
+                </a:solidFill>
+              </a:defRPr>
+            </a:lvl2pPr>
+            <a:lvl3pPr>
+              <a:defRPr>
+                <a:solidFill>
+                  <a:srgbClr val="FFC000"/>
+                </a:solidFill>
+              </a:defRPr>
+            </a:lvl3pPr>
+            <a:lvl4pPr>
+              <a:defRPr>
+                <a:solidFill>
+                  <a:srgbClr val="FFC000"/>
+                </a:solidFill>
+              </a:defRPr>
+            </a:lvl4pPr>
+            <a:lvl5pPr>
+              <a:defRPr>
+                <a:solidFill>
+                  <a:srgbClr val="FFC000"/>
+                </a:solidFill>
+              </a:defRPr>
+            </a:lvl5pPr>
+          </a:lstStyle>
+          <a:p>
+            <a:pPr lvl="0"/>
+            <a:r>
+              <a:rPr lang="en-US" dirty="0"/>
+              <a:t>X%</a:t>
+            </a:r>
+            <a:endParaRPr lang="en-AU" dirty="0"/>
+          </a:p>
+        </p:txBody>
+      </p:sp>
+      <p:grpSp>
+        <p:nvGrpSpPr>
+          <p:cNvPr id="7" name="grp_NCR10">
+            <a:extLst>
+              <a:ext uri="{FF2B5EF4-FFF2-40B4-BE49-F238E27FC236}">
+                <a16:creationId xmlns:a16="http://schemas.microsoft.com/office/drawing/2014/main" id="{EED5867F-A84D-6E58-FB95-56F2A0386961}"/>
+              </a:ext>
+            </a:extLst>
+          </p:cNvPr>
+          <p:cNvGrpSpPr/>
+          <p:nvPr userDrawn="1"/>
+        </p:nvGrpSpPr>
+        <p:grpSpPr>
+          <a:xfrm>
+            <a:off x="1912706" y="6691067"/>
+            <a:ext cx="1193545" cy="900000"/>
+            <a:chOff x="1887992" y="7049420"/>
+            <a:chExt cx="1193545" cy="900000"/>
+          </a:xfrm>
+        </p:grpSpPr>
+        <p:sp>
+          <p:nvSpPr>
+            <p:cNvPr id="15" name="shp_NCR10">
+              <a:extLst>
+                <a:ext uri="{FF2B5EF4-FFF2-40B4-BE49-F238E27FC236}">
+                  <a16:creationId xmlns:a16="http://schemas.microsoft.com/office/drawing/2014/main" id="{0CFD3C25-6057-A68F-D7E4-8752A2F67E93}"/>
+                </a:ext>
+              </a:extLst>
+            </p:cNvPr>
+            <p:cNvSpPr/>
+            <p:nvPr userDrawn="1"/>
+          </p:nvSpPr>
+          <p:spPr>
+            <a:xfrm>
+              <a:off x="2034184" y="7049420"/>
+              <a:ext cx="900000" cy="900000"/>
+            </a:xfrm>
+            <a:prstGeom prst="ellipse">
+              <a:avLst/>
+            </a:prstGeom>
+            <a:solidFill>
+              <a:srgbClr val="FFC000"/>
+            </a:solidFill>
+            <a:ln>
+              <a:noFill/>
+            </a:ln>
+          </p:spPr>
+          <p:style>
+            <a:lnRef idx="2">
+              <a:schemeClr val="accent1">
+                <a:shade val="50000"/>
+              </a:schemeClr>
+            </a:lnRef>
+            <a:fillRef idx="1">
+              <a:schemeClr val="accent1"/>
+            </a:fillRef>
+            <a:effectRef idx="0">
+              <a:schemeClr val="accent1"/>
+            </a:effectRef>
+            <a:fontRef idx="minor">
+              <a:schemeClr val="lt1"/>
+            </a:fontRef>
+          </p:style>
+          <p:txBody>
+            <a:bodyPr rtlCol="0" anchor="ctr"/>
+            <a:lstStyle/>
+            <a:p>
+              <a:pPr algn="ctr"/>
+              <a:endParaRPr lang="en-AU" sz="1801" dirty="0">
+                <a:solidFill>
+                  <a:schemeClr val="accent1"/>
+                </a:solidFill>
+              </a:endParaRPr>
+            </a:p>
+          </p:txBody>
+        </p:sp>
+        <p:pic>
+          <p:nvPicPr>
+            <p:cNvPr id="96" name="pic_NCR10">
+              <a:extLst>
+                <a:ext uri="{FF2B5EF4-FFF2-40B4-BE49-F238E27FC236}">
+                  <a16:creationId xmlns:a16="http://schemas.microsoft.com/office/drawing/2014/main" id="{45022D99-4D6F-EC4D-B596-181CE3D268A0}"/>
+                </a:ext>
+              </a:extLst>
+            </p:cNvPr>
+            <p:cNvPicPr>
+              <a:picLocks noChangeAspect="1"/>
+            </p:cNvPicPr>
+            <p:nvPr userDrawn="1"/>
+          </p:nvPicPr>
+          <p:blipFill>
+            <a:blip r:embed="rId7" cstate="screen">
+              <a:extLst>
+                <a:ext uri="{BEBA8EAE-BF5A-486C-A8C5-ECC9F3942E4B}">
+                  <a14:imgProps xmlns:a14="http://schemas.microsoft.com/office/drawing/2010/main">
+                    <a14:imgLayer r:embed="rId8">
+                      <a14:imgEffect>
+                        <a14:backgroundRemoval t="9020" b="95686" l="10000" r="89767">
+                          <a14:foregroundMark x1="28837" y1="9804" x2="44651" y2="9804"/>
+                          <a14:foregroundMark x1="55581" y1="9020" x2="69767" y2="9020"/>
+                          <a14:foregroundMark x1="31628" y1="52941" x2="37442" y2="63922"/>
+                          <a14:foregroundMark x1="55116" y1="27059" x2="66279" y2="43137"/>
+                          <a14:foregroundMark x1="66279" y1="19608" x2="65814" y2="34902"/>
+                          <a14:foregroundMark x1="30233" y1="17255" x2="30698" y2="23137"/>
+                          <a14:foregroundMark x1="30930" y1="90588" x2="47907" y2="96078"/>
+                          <a14:foregroundMark x1="47907" y1="96078" x2="71163" y2="90196"/>
+                        </a14:backgroundRemoval>
+                      </a14:imgEffect>
+                    </a14:imgLayer>
+                  </a14:imgProps>
+                </a:ext>
+                <a:ext uri="{28A0092B-C50C-407E-A947-70E740481C1C}">
+                  <a14:useLocalDpi xmlns:a14="http://schemas.microsoft.com/office/drawing/2010/main"/>
+                </a:ext>
+              </a:extLst>
+            </a:blip>
+            <a:srcRect/>
+            <a:stretch/>
+          </p:blipFill>
+          <p:spPr>
+            <a:xfrm>
+              <a:off x="1887992" y="7156664"/>
+              <a:ext cx="1193545" cy="710398"/>
+            </a:xfrm>
+            <a:prstGeom prst="rect">
+              <a:avLst/>
+            </a:prstGeom>
+          </p:spPr>
+        </p:pic>
+      </p:grpSp>
+      <p:sp>
+        <p:nvSpPr>
+          <p:cNvPr id="3" name="ph_NCR2_desc2">
+            <a:extLst>
+              <a:ext uri="{FF2B5EF4-FFF2-40B4-BE49-F238E27FC236}">
+                <a16:creationId xmlns:a16="http://schemas.microsoft.com/office/drawing/2014/main" id="{10F35289-C14E-D8DC-E6F0-74A1CC6A06E4}"/>
+              </a:ext>
+            </a:extLst>
+          </p:cNvPr>
+          <p:cNvSpPr txBox="1"/>
+          <p:nvPr userDrawn="1"/>
+        </p:nvSpPr>
+        <p:spPr>
+          <a:xfrm>
+            <a:off x="27015" y="5937773"/>
+            <a:ext cx="2051342" cy="338554"/>
+          </a:xfrm>
+          <a:prstGeom prst="rect">
+            <a:avLst/>
+          </a:prstGeom>
+          <a:noFill/>
+        </p:spPr>
+        <p:txBody>
+          <a:bodyPr wrap="square" lIns="72000" tIns="0" rIns="0" bIns="0" rtlCol="0">
+            <a:spAutoFit/>
+          </a:bodyPr>
+          <a:lstStyle/>
+          <a:p>
+            <a:r>
+              <a:rPr lang="en-AU" sz="1100" dirty="0"/>
+              <a:t>* direct or pre-hospital activated STEMI with chest pain &lt;12 hours</a:t>
+            </a:r>
+          </a:p>
+        </p:txBody>
+      </p:sp>
+      <p:sp>
+        <p:nvSpPr>
+          <p:cNvPr id="39" name="ph_NCR2_desc">
+            <a:extLst>
+              <a:ext uri="{FF2B5EF4-FFF2-40B4-BE49-F238E27FC236}">
+                <a16:creationId xmlns:a16="http://schemas.microsoft.com/office/drawing/2014/main" id="{2BD6D79E-3784-39A1-5BE0-598EDD61CF3D}"/>
+              </a:ext>
+            </a:extLst>
+          </p:cNvPr>
+          <p:cNvSpPr>
+            <a:spLocks noGrp="1"/>
+          </p:cNvSpPr>
+          <p:nvPr>
+            <p:ph type="body" sz="quarter" idx="10" hasCustomPrompt="1"/>
+          </p:nvPr>
+        </p:nvSpPr>
+        <p:spPr>
+          <a:xfrm>
+            <a:off x="27015" y="5476869"/>
+            <a:ext cx="2051342" cy="438403"/>
+          </a:xfrm>
+          <a:prstGeom prst="rect">
+            <a:avLst/>
+          </a:prstGeom>
+        </p:spPr>
+        <p:txBody>
+          <a:bodyPr lIns="0" tIns="0" rIns="0" bIns="0"/>
+          <a:lstStyle>
+            <a:lvl1pPr marL="0" indent="0" algn="r">
+              <a:buNone/>
+              <a:defRPr sz="1600"/>
+            </a:lvl1pPr>
+          </a:lstStyle>
+          <a:p>
+            <a:pPr lvl="0"/>
+            <a:r>
+              <a:rPr lang="en-AU" dirty="0"/>
+              <a:t>Median Door to Device time was X min</a:t>
+            </a:r>
+          </a:p>
+        </p:txBody>
+      </p:sp>
+      <p:sp>
+        <p:nvSpPr>
+          <p:cNvPr id="5" name="ph_NCR2_mins">
             <a:extLst>
               <a:ext uri="{FF2B5EF4-FFF2-40B4-BE49-F238E27FC236}">
                 <a16:creationId xmlns:a16="http://schemas.microsoft.com/office/drawing/2014/main" id="{C71ECDB7-514B-3457-61EC-0EDD81FFB2F9}"/>
@@ -1700,668 +2401,9 @@
           </a:p>
         </p:txBody>
       </p:sp>
-      <p:grpSp>
-        <p:nvGrpSpPr>
-          <p:cNvPr id="2" name="radial">
-            <a:extLst>
-              <a:ext uri="{FF2B5EF4-FFF2-40B4-BE49-F238E27FC236}">
-                <a16:creationId xmlns:a16="http://schemas.microsoft.com/office/drawing/2014/main" id="{B5E3AA50-0418-452B-C37C-6A5EE4384741}"/>
-              </a:ext>
-            </a:extLst>
-          </p:cNvPr>
-          <p:cNvGrpSpPr/>
-          <p:nvPr userDrawn="1"/>
-        </p:nvGrpSpPr>
-        <p:grpSpPr>
-          <a:xfrm>
-            <a:off x="4721340" y="4301898"/>
-            <a:ext cx="900000" cy="900000"/>
-            <a:chOff x="4622484" y="4969171"/>
-            <a:chExt cx="900000" cy="900000"/>
-          </a:xfrm>
-        </p:grpSpPr>
-        <p:sp>
-          <p:nvSpPr>
-            <p:cNvPr id="18" name="shp_radial">
-              <a:extLst>
-                <a:ext uri="{FF2B5EF4-FFF2-40B4-BE49-F238E27FC236}">
-                  <a16:creationId xmlns:a16="http://schemas.microsoft.com/office/drawing/2014/main" id="{F398ED92-E238-6D9E-B3F0-984D6E2E8650}"/>
-                </a:ext>
-              </a:extLst>
-            </p:cNvPr>
-            <p:cNvSpPr/>
-            <p:nvPr userDrawn="1"/>
-          </p:nvSpPr>
-          <p:spPr>
-            <a:xfrm>
-              <a:off x="4622484" y="4969171"/>
-              <a:ext cx="900000" cy="900000"/>
-            </a:xfrm>
-            <a:prstGeom prst="ellipse">
-              <a:avLst/>
-            </a:prstGeom>
-            <a:solidFill>
-              <a:schemeClr val="accent5">
-                <a:lumMod val="60000"/>
-                <a:lumOff val="40000"/>
-              </a:schemeClr>
-            </a:solidFill>
-            <a:ln>
-              <a:noFill/>
-            </a:ln>
-          </p:spPr>
-          <p:style>
-            <a:lnRef idx="2">
-              <a:schemeClr val="accent1">
-                <a:shade val="50000"/>
-              </a:schemeClr>
-            </a:lnRef>
-            <a:fillRef idx="1">
-              <a:schemeClr val="accent1"/>
-            </a:fillRef>
-            <a:effectRef idx="0">
-              <a:schemeClr val="accent1"/>
-            </a:effectRef>
-            <a:fontRef idx="minor">
-              <a:schemeClr val="lt1"/>
-            </a:fontRef>
-          </p:style>
-          <p:txBody>
-            <a:bodyPr rtlCol="0" anchor="ctr"/>
-            <a:lstStyle/>
-            <a:p>
-              <a:pPr algn="ctr"/>
-              <a:endParaRPr lang="en-AU" sz="1801" dirty="0">
-                <a:solidFill>
-                  <a:schemeClr val="accent1"/>
-                </a:solidFill>
-              </a:endParaRPr>
-            </a:p>
-          </p:txBody>
-        </p:sp>
-        <p:pic>
-          <p:nvPicPr>
-            <p:cNvPr id="12" name="icon_radial">
-              <a:extLst>
-                <a:ext uri="{FF2B5EF4-FFF2-40B4-BE49-F238E27FC236}">
-                  <a16:creationId xmlns:a16="http://schemas.microsoft.com/office/drawing/2014/main" id="{4A335C9F-C929-90C4-EE54-C3B0862F27AB}"/>
-                </a:ext>
-              </a:extLst>
-            </p:cNvPr>
-            <p:cNvPicPr>
-              <a:picLocks noChangeAspect="1"/>
-            </p:cNvPicPr>
-            <p:nvPr userDrawn="1"/>
-          </p:nvPicPr>
-          <p:blipFill>
-            <a:blip r:embed="rId4">
-              <a:clrChange>
-                <a:clrFrom>
-                  <a:srgbClr val="000000"/>
-                </a:clrFrom>
-                <a:clrTo>
-                  <a:srgbClr val="000000">
-                    <a:alpha val="0"/>
-                  </a:srgbClr>
-                </a:clrTo>
-              </a:clrChange>
-              <a:extLst>
-                <a:ext uri="{BEBA8EAE-BF5A-486C-A8C5-ECC9F3942E4B}">
-                  <a14:imgProps xmlns:a14="http://schemas.microsoft.com/office/drawing/2010/main">
-                    <a14:imgLayer r:embed="rId5">
-                      <a14:imgEffect>
-                        <a14:backgroundRemoval t="10000" b="90000" l="10000" r="90000">
-                          <a14:foregroundMark x1="42383" y1="45117" x2="42383" y2="45117"/>
-                          <a14:foregroundMark x1="44141" y1="45605" x2="44141" y2="45605"/>
-                          <a14:foregroundMark x1="46777" y1="45703" x2="46777" y2="45703"/>
-                          <a14:foregroundMark x1="52734" y1="45996" x2="52734" y2="45996"/>
-                          <a14:foregroundMark x1="54492" y1="45996" x2="54492" y2="45996"/>
-                          <a14:foregroundMark x1="49805" y1="49121" x2="49805" y2="49121"/>
-                          <a14:foregroundMark x1="56738" y1="45605" x2="56738" y2="45605"/>
-                          <a14:foregroundMark x1="58887" y1="45996" x2="58887" y2="45996"/>
-                          <a14:foregroundMark x1="60547" y1="45801" x2="60547" y2="45801"/>
-                          <a14:foregroundMark x1="62988" y1="45996" x2="62988" y2="45996"/>
-                          <a14:foregroundMark x1="65723" y1="46191" x2="65723" y2="46191"/>
-                          <a14:foregroundMark x1="67188" y1="46191" x2="67188" y2="46191"/>
-                          <a14:foregroundMark x1="69336" y1="46094" x2="69336" y2="46094"/>
-                          <a14:foregroundMark x1="71875" y1="45996" x2="71875" y2="45996"/>
-                          <a14:foregroundMark x1="73730" y1="46582" x2="73730" y2="46582"/>
-                          <a14:foregroundMark x1="75684" y1="46777" x2="75684" y2="46777"/>
-                          <a14:foregroundMark x1="77637" y1="47656" x2="77637" y2="47656"/>
-                        </a14:backgroundRemoval>
-                      </a14:imgEffect>
-                    </a14:imgLayer>
-                  </a14:imgProps>
-                </a:ext>
-              </a:extLst>
-            </a:blip>
-            <a:srcRect l="9320" t="28301" r="45829" b="33282"/>
-            <a:stretch/>
-          </p:blipFill>
-          <p:spPr>
-            <a:xfrm rot="1623292">
-              <a:off x="4663014" y="5011030"/>
-              <a:ext cx="848642" cy="726915"/>
-            </a:xfrm>
-            <a:prstGeom prst="rect">
-              <a:avLst/>
-            </a:prstGeom>
-          </p:spPr>
-        </p:pic>
-      </p:grpSp>
       <p:sp>
         <p:nvSpPr>
-          <p:cNvPr id="47" name="ph_stemi_pct">
-            <a:extLst>
-              <a:ext uri="{FF2B5EF4-FFF2-40B4-BE49-F238E27FC236}">
-                <a16:creationId xmlns:a16="http://schemas.microsoft.com/office/drawing/2014/main" id="{B1F62D07-2195-698B-2714-154E4501E4EB}"/>
-              </a:ext>
-            </a:extLst>
-          </p:cNvPr>
-          <p:cNvSpPr>
-            <a:spLocks noGrp="1"/>
-          </p:cNvSpPr>
-          <p:nvPr>
-            <p:ph type="body" sz="quarter" idx="27" hasCustomPrompt="1"/>
-          </p:nvPr>
-        </p:nvSpPr>
-        <p:spPr>
-          <a:xfrm>
-            <a:off x="5019163" y="2792147"/>
-            <a:ext cx="1516977" cy="504000"/>
-          </a:xfrm>
-          <a:prstGeom prst="rect">
-            <a:avLst/>
-          </a:prstGeom>
-        </p:spPr>
-        <p:txBody>
-          <a:bodyPr lIns="0" tIns="0" rIns="0" bIns="0" anchor="ctr" anchorCtr="0"/>
-          <a:lstStyle>
-            <a:lvl1pPr marL="0" indent="0" algn="l">
-              <a:buNone/>
-              <a:defRPr sz="4800">
-                <a:solidFill>
-                  <a:srgbClr val="133F6D"/>
-                </a:solidFill>
-              </a:defRPr>
-            </a:lvl1pPr>
-            <a:lvl2pPr>
-              <a:defRPr>
-                <a:solidFill>
-                  <a:srgbClr val="133F6D"/>
-                </a:solidFill>
-              </a:defRPr>
-            </a:lvl2pPr>
-            <a:lvl3pPr>
-              <a:defRPr>
-                <a:solidFill>
-                  <a:srgbClr val="133F6D"/>
-                </a:solidFill>
-              </a:defRPr>
-            </a:lvl3pPr>
-            <a:lvl4pPr>
-              <a:defRPr>
-                <a:solidFill>
-                  <a:srgbClr val="133F6D"/>
-                </a:solidFill>
-              </a:defRPr>
-            </a:lvl4pPr>
-            <a:lvl5pPr>
-              <a:defRPr>
-                <a:solidFill>
-                  <a:srgbClr val="133F6D"/>
-                </a:solidFill>
-              </a:defRPr>
-            </a:lvl5pPr>
-          </a:lstStyle>
-          <a:p>
-            <a:pPr lvl="0"/>
-            <a:r>
-              <a:rPr lang="en-US" dirty="0"/>
-              <a:t>X%</a:t>
-            </a:r>
-            <a:endParaRPr lang="en-AU" dirty="0"/>
-          </a:p>
-        </p:txBody>
-      </p:sp>
-      <p:sp>
-        <p:nvSpPr>
-          <p:cNvPr id="41" name="ph_stemi">
-            <a:extLst>
-              <a:ext uri="{FF2B5EF4-FFF2-40B4-BE49-F238E27FC236}">
-                <a16:creationId xmlns:a16="http://schemas.microsoft.com/office/drawing/2014/main" id="{D4F00C51-9060-7169-179B-F541DAFC0C7E}"/>
-              </a:ext>
-            </a:extLst>
-          </p:cNvPr>
-          <p:cNvSpPr>
-            <a:spLocks noGrp="1"/>
-          </p:cNvSpPr>
-          <p:nvPr>
-            <p:ph type="body" sz="quarter" idx="15" hasCustomPrompt="1"/>
-          </p:nvPr>
-        </p:nvSpPr>
-        <p:spPr>
-          <a:xfrm>
-            <a:off x="4266801" y="3585199"/>
-            <a:ext cx="2500255" cy="610343"/>
-          </a:xfrm>
-          <a:prstGeom prst="rect">
-            <a:avLst/>
-          </a:prstGeom>
-        </p:spPr>
-        <p:txBody>
-          <a:bodyPr lIns="0" tIns="0" rIns="0" bIns="0"/>
-          <a:lstStyle>
-            <a:lvl1pPr marL="0" indent="0" algn="l">
-              <a:buNone/>
-              <a:defRPr sz="1600"/>
-            </a:lvl1pPr>
-          </a:lstStyle>
-          <a:p>
-            <a:pPr lvl="0"/>
-            <a:r>
-              <a:rPr lang="en-AU" dirty="0"/>
-              <a:t>X of Y PCI were emergencies for STEMI</a:t>
-            </a:r>
-          </a:p>
-        </p:txBody>
-      </p:sp>
-      <p:grpSp>
-        <p:nvGrpSpPr>
-          <p:cNvPr id="8" name="stemi">
-            <a:extLst>
-              <a:ext uri="{FF2B5EF4-FFF2-40B4-BE49-F238E27FC236}">
-                <a16:creationId xmlns:a16="http://schemas.microsoft.com/office/drawing/2014/main" id="{48F6A469-26C0-EA12-0433-BAE178F0D17F}"/>
-              </a:ext>
-            </a:extLst>
-          </p:cNvPr>
-          <p:cNvGrpSpPr/>
-          <p:nvPr userDrawn="1"/>
-        </p:nvGrpSpPr>
-        <p:grpSpPr>
-          <a:xfrm>
-            <a:off x="3804989" y="2399161"/>
-            <a:ext cx="1138003" cy="1138003"/>
-            <a:chOff x="3804989" y="2621587"/>
-            <a:chExt cx="1138003" cy="1138003"/>
-          </a:xfrm>
-        </p:grpSpPr>
-        <p:sp>
-          <p:nvSpPr>
-            <p:cNvPr id="22" name="shp_stemi">
-              <a:extLst>
-                <a:ext uri="{FF2B5EF4-FFF2-40B4-BE49-F238E27FC236}">
-                  <a16:creationId xmlns:a16="http://schemas.microsoft.com/office/drawing/2014/main" id="{A79E2BBB-6172-9A7B-B7D2-88173061667A}"/>
-                </a:ext>
-              </a:extLst>
-            </p:cNvPr>
-            <p:cNvSpPr/>
-            <p:nvPr userDrawn="1"/>
-          </p:nvSpPr>
-          <p:spPr>
-            <a:xfrm>
-              <a:off x="3911092" y="2786713"/>
-              <a:ext cx="900000" cy="900000"/>
-            </a:xfrm>
-            <a:prstGeom prst="ellipse">
-              <a:avLst/>
-            </a:prstGeom>
-            <a:solidFill>
-              <a:schemeClr val="accent1"/>
-            </a:solidFill>
-            <a:ln>
-              <a:noFill/>
-            </a:ln>
-          </p:spPr>
-          <p:style>
-            <a:lnRef idx="2">
-              <a:schemeClr val="accent1">
-                <a:shade val="50000"/>
-              </a:schemeClr>
-            </a:lnRef>
-            <a:fillRef idx="1">
-              <a:schemeClr val="accent1"/>
-            </a:fillRef>
-            <a:effectRef idx="0">
-              <a:schemeClr val="accent1"/>
-            </a:effectRef>
-            <a:fontRef idx="minor">
-              <a:schemeClr val="lt1"/>
-            </a:fontRef>
-          </p:style>
-          <p:txBody>
-            <a:bodyPr rtlCol="0" anchor="ctr"/>
-            <a:lstStyle/>
-            <a:p>
-              <a:pPr algn="ctr"/>
-              <a:endParaRPr lang="en-AU" sz="1801" dirty="0">
-                <a:solidFill>
-                  <a:schemeClr val="accent1"/>
-                </a:solidFill>
-              </a:endParaRPr>
-            </a:p>
-          </p:txBody>
-        </p:sp>
-        <p:pic>
-          <p:nvPicPr>
-            <p:cNvPr id="24" name="pic_stemi">
-              <a:extLst>
-                <a:ext uri="{FF2B5EF4-FFF2-40B4-BE49-F238E27FC236}">
-                  <a16:creationId xmlns:a16="http://schemas.microsoft.com/office/drawing/2014/main" id="{C4803C3E-DE7F-2182-D796-F9D9BADE5615}"/>
-                </a:ext>
-              </a:extLst>
-            </p:cNvPr>
-            <p:cNvPicPr>
-              <a:picLocks noChangeAspect="1"/>
-            </p:cNvPicPr>
-            <p:nvPr userDrawn="1"/>
-          </p:nvPicPr>
-          <p:blipFill>
-            <a:blip r:embed="rId6"/>
-            <a:stretch>
-              <a:fillRect/>
-            </a:stretch>
-          </p:blipFill>
-          <p:spPr>
-            <a:xfrm>
-              <a:off x="3804989" y="2621587"/>
-              <a:ext cx="1138003" cy="1138003"/>
-            </a:xfrm>
-            <a:prstGeom prst="rect">
-              <a:avLst/>
-            </a:prstGeom>
-          </p:spPr>
-        </p:pic>
-      </p:grpSp>
-      <p:sp>
-        <p:nvSpPr>
-          <p:cNvPr id="50" name="ph_crehab_pct">
-            <a:extLst>
-              <a:ext uri="{FF2B5EF4-FFF2-40B4-BE49-F238E27FC236}">
-                <a16:creationId xmlns:a16="http://schemas.microsoft.com/office/drawing/2014/main" id="{A8C0D454-B653-61F4-5751-F6813F0ADF7C}"/>
-              </a:ext>
-            </a:extLst>
-          </p:cNvPr>
-          <p:cNvSpPr>
-            <a:spLocks noGrp="1"/>
-          </p:cNvSpPr>
-          <p:nvPr>
-            <p:ph type="body" sz="quarter" idx="30" hasCustomPrompt="1"/>
-          </p:nvPr>
-        </p:nvSpPr>
-        <p:spPr>
-          <a:xfrm>
-            <a:off x="461442" y="6935565"/>
-            <a:ext cx="1548000" cy="504000"/>
-          </a:xfrm>
-          <a:prstGeom prst="rect">
-            <a:avLst/>
-          </a:prstGeom>
-        </p:spPr>
-        <p:txBody>
-          <a:bodyPr lIns="0" tIns="0" rIns="0" bIns="0" anchor="ctr" anchorCtr="0"/>
-          <a:lstStyle>
-            <a:lvl1pPr marL="0" indent="0" algn="r">
-              <a:buNone/>
-              <a:defRPr sz="4800">
-                <a:solidFill>
-                  <a:srgbClr val="FFC000"/>
-                </a:solidFill>
-              </a:defRPr>
-            </a:lvl1pPr>
-            <a:lvl2pPr>
-              <a:defRPr>
-                <a:solidFill>
-                  <a:srgbClr val="FFC000"/>
-                </a:solidFill>
-              </a:defRPr>
-            </a:lvl2pPr>
-            <a:lvl3pPr>
-              <a:defRPr>
-                <a:solidFill>
-                  <a:srgbClr val="FFC000"/>
-                </a:solidFill>
-              </a:defRPr>
-            </a:lvl3pPr>
-            <a:lvl4pPr>
-              <a:defRPr>
-                <a:solidFill>
-                  <a:srgbClr val="FFC000"/>
-                </a:solidFill>
-              </a:defRPr>
-            </a:lvl4pPr>
-            <a:lvl5pPr>
-              <a:defRPr>
-                <a:solidFill>
-                  <a:srgbClr val="FFC000"/>
-                </a:solidFill>
-              </a:defRPr>
-            </a:lvl5pPr>
-          </a:lstStyle>
-          <a:p>
-            <a:pPr lvl="0"/>
-            <a:r>
-              <a:rPr lang="en-US" dirty="0"/>
-              <a:t>X%</a:t>
-            </a:r>
-            <a:endParaRPr lang="en-AU" dirty="0"/>
-          </a:p>
-        </p:txBody>
-      </p:sp>
-      <p:sp>
-        <p:nvSpPr>
-          <p:cNvPr id="42" name="ph_crehab">
-            <a:extLst>
-              <a:ext uri="{FF2B5EF4-FFF2-40B4-BE49-F238E27FC236}">
-                <a16:creationId xmlns:a16="http://schemas.microsoft.com/office/drawing/2014/main" id="{EF9CBF36-A38B-ED1E-AFAF-CEAD51735C04}"/>
-              </a:ext>
-            </a:extLst>
-          </p:cNvPr>
-          <p:cNvSpPr>
-            <a:spLocks noGrp="1"/>
-          </p:cNvSpPr>
-          <p:nvPr>
-            <p:ph type="body" sz="quarter" idx="14" hasCustomPrompt="1"/>
-          </p:nvPr>
-        </p:nvSpPr>
-        <p:spPr>
-          <a:xfrm>
-            <a:off x="369771" y="7791190"/>
-            <a:ext cx="2630768" cy="823559"/>
-          </a:xfrm>
-          <a:prstGeom prst="rect">
-            <a:avLst/>
-          </a:prstGeom>
-        </p:spPr>
-        <p:txBody>
-          <a:bodyPr lIns="0" tIns="0" rIns="0" bIns="0"/>
-          <a:lstStyle>
-            <a:lvl1pPr marL="0" indent="0" algn="r">
-              <a:buNone/>
-              <a:defRPr sz="1600"/>
-            </a:lvl1pPr>
-          </a:lstStyle>
-          <a:p>
-            <a:pPr lvl="0"/>
-            <a:r>
-              <a:rPr lang="en-GB" dirty="0"/>
-              <a:t>Evidence of referral to Cardiac Rehab was available in </a:t>
-            </a:r>
-            <a:r>
-              <a:rPr lang="en-AU" dirty="0"/>
-              <a:t>X out of Y patients</a:t>
-            </a:r>
-          </a:p>
-        </p:txBody>
-      </p:sp>
-      <p:grpSp>
-        <p:nvGrpSpPr>
-          <p:cNvPr id="7" name="crehab">
-            <a:extLst>
-              <a:ext uri="{FF2B5EF4-FFF2-40B4-BE49-F238E27FC236}">
-                <a16:creationId xmlns:a16="http://schemas.microsoft.com/office/drawing/2014/main" id="{EED5867F-A84D-6E58-FB95-56F2A0386961}"/>
-              </a:ext>
-            </a:extLst>
-          </p:cNvPr>
-          <p:cNvGrpSpPr/>
-          <p:nvPr userDrawn="1"/>
-        </p:nvGrpSpPr>
-        <p:grpSpPr>
-          <a:xfrm>
-            <a:off x="1912706" y="6691067"/>
-            <a:ext cx="1193545" cy="900000"/>
-            <a:chOff x="1887992" y="7049420"/>
-            <a:chExt cx="1193545" cy="900000"/>
-          </a:xfrm>
-        </p:grpSpPr>
-        <p:sp>
-          <p:nvSpPr>
-            <p:cNvPr id="15" name="shp_circle_yellow">
-              <a:extLst>
-                <a:ext uri="{FF2B5EF4-FFF2-40B4-BE49-F238E27FC236}">
-                  <a16:creationId xmlns:a16="http://schemas.microsoft.com/office/drawing/2014/main" id="{0CFD3C25-6057-A68F-D7E4-8752A2F67E93}"/>
-                </a:ext>
-              </a:extLst>
-            </p:cNvPr>
-            <p:cNvSpPr/>
-            <p:nvPr userDrawn="1"/>
-          </p:nvSpPr>
-          <p:spPr>
-            <a:xfrm>
-              <a:off x="2034184" y="7049420"/>
-              <a:ext cx="900000" cy="900000"/>
-            </a:xfrm>
-            <a:prstGeom prst="ellipse">
-              <a:avLst/>
-            </a:prstGeom>
-            <a:solidFill>
-              <a:srgbClr val="FFC000"/>
-            </a:solidFill>
-            <a:ln>
-              <a:noFill/>
-            </a:ln>
-          </p:spPr>
-          <p:style>
-            <a:lnRef idx="2">
-              <a:schemeClr val="accent1">
-                <a:shade val="50000"/>
-              </a:schemeClr>
-            </a:lnRef>
-            <a:fillRef idx="1">
-              <a:schemeClr val="accent1"/>
-            </a:fillRef>
-            <a:effectRef idx="0">
-              <a:schemeClr val="accent1"/>
-            </a:effectRef>
-            <a:fontRef idx="minor">
-              <a:schemeClr val="lt1"/>
-            </a:fontRef>
-          </p:style>
-          <p:txBody>
-            <a:bodyPr rtlCol="0" anchor="ctr"/>
-            <a:lstStyle/>
-            <a:p>
-              <a:pPr algn="ctr"/>
-              <a:endParaRPr lang="en-AU" sz="1801" dirty="0">
-                <a:solidFill>
-                  <a:schemeClr val="accent1"/>
-                </a:solidFill>
-              </a:endParaRPr>
-            </a:p>
-          </p:txBody>
-        </p:sp>
-        <p:pic>
-          <p:nvPicPr>
-            <p:cNvPr id="96" name="pic_crehab">
-              <a:extLst>
-                <a:ext uri="{FF2B5EF4-FFF2-40B4-BE49-F238E27FC236}">
-                  <a16:creationId xmlns:a16="http://schemas.microsoft.com/office/drawing/2014/main" id="{45022D99-4D6F-EC4D-B596-181CE3D268A0}"/>
-                </a:ext>
-              </a:extLst>
-            </p:cNvPr>
-            <p:cNvPicPr>
-              <a:picLocks noChangeAspect="1"/>
-            </p:cNvPicPr>
-            <p:nvPr userDrawn="1"/>
-          </p:nvPicPr>
-          <p:blipFill>
-            <a:blip r:embed="rId7" cstate="screen">
-              <a:extLst>
-                <a:ext uri="{BEBA8EAE-BF5A-486C-A8C5-ECC9F3942E4B}">
-                  <a14:imgProps xmlns:a14="http://schemas.microsoft.com/office/drawing/2010/main">
-                    <a14:imgLayer r:embed="rId8">
-                      <a14:imgEffect>
-                        <a14:backgroundRemoval t="9020" b="95686" l="10000" r="89767">
-                          <a14:foregroundMark x1="28837" y1="9804" x2="44651" y2="9804"/>
-                          <a14:foregroundMark x1="55581" y1="9020" x2="69767" y2="9020"/>
-                          <a14:foregroundMark x1="31628" y1="52941" x2="37442" y2="63922"/>
-                          <a14:foregroundMark x1="55116" y1="27059" x2="66279" y2="43137"/>
-                          <a14:foregroundMark x1="66279" y1="19608" x2="65814" y2="34902"/>
-                          <a14:foregroundMark x1="30233" y1="17255" x2="30698" y2="23137"/>
-                          <a14:foregroundMark x1="30930" y1="90588" x2="47907" y2="96078"/>
-                          <a14:foregroundMark x1="47907" y1="96078" x2="71163" y2="90196"/>
-                        </a14:backgroundRemoval>
-                      </a14:imgEffect>
-                    </a14:imgLayer>
-                  </a14:imgProps>
-                </a:ext>
-                <a:ext uri="{28A0092B-C50C-407E-A947-70E740481C1C}">
-                  <a14:useLocalDpi xmlns:a14="http://schemas.microsoft.com/office/drawing/2010/main"/>
-                </a:ext>
-              </a:extLst>
-            </a:blip>
-            <a:srcRect/>
-            <a:stretch/>
-          </p:blipFill>
-          <p:spPr>
-            <a:xfrm>
-              <a:off x="1887992" y="7156664"/>
-              <a:ext cx="1193545" cy="710398"/>
-            </a:xfrm>
-            <a:prstGeom prst="rect">
-              <a:avLst/>
-            </a:prstGeom>
-          </p:spPr>
-        </p:pic>
-      </p:grpSp>
-      <p:sp>
-        <p:nvSpPr>
-          <p:cNvPr id="3" name="ph_door_to_reperfusion_additional_text">
-            <a:extLst>
-              <a:ext uri="{FF2B5EF4-FFF2-40B4-BE49-F238E27FC236}">
-                <a16:creationId xmlns:a16="http://schemas.microsoft.com/office/drawing/2014/main" id="{10F35289-C14E-D8DC-E6F0-74A1CC6A06E4}"/>
-              </a:ext>
-            </a:extLst>
-          </p:cNvPr>
-          <p:cNvSpPr txBox="1"/>
-          <p:nvPr userDrawn="1"/>
-        </p:nvSpPr>
-        <p:spPr>
-          <a:xfrm>
-            <a:off x="27015" y="5937773"/>
-            <a:ext cx="2051342" cy="338554"/>
-          </a:xfrm>
-          <a:prstGeom prst="rect">
-            <a:avLst/>
-          </a:prstGeom>
-          <a:noFill/>
-        </p:spPr>
-        <p:txBody>
-          <a:bodyPr wrap="square" lIns="72000" tIns="0" rIns="0" bIns="0" rtlCol="0">
-            <a:spAutoFit/>
-          </a:bodyPr>
-          <a:lstStyle/>
-          <a:p>
-            <a:r>
-              <a:rPr lang="en-AU" sz="1100" dirty="0"/>
-              <a:t>* direct or pre-hospital activated STEMI with chest pain &lt;12 hours</a:t>
-            </a:r>
-          </a:p>
-        </p:txBody>
-      </p:sp>
-      <p:sp>
-        <p:nvSpPr>
-          <p:cNvPr id="46" name="ph_door_to_reperfusion_pct">
+          <p:cNvPr id="46" name="ph_NCR2_value">
             <a:extLst>
               <a:ext uri="{FF2B5EF4-FFF2-40B4-BE49-F238E27FC236}">
                 <a16:creationId xmlns:a16="http://schemas.microsoft.com/office/drawing/2014/main" id="{6C6C5E27-B920-6468-D3D0-CF1BF1645A0B}"/>
@@ -2434,51 +2476,9 @@
           </a:p>
         </p:txBody>
       </p:sp>
-      <p:sp>
-        <p:nvSpPr>
-          <p:cNvPr id="39" name="ph_door_to_reperfusion">
-            <a:extLst>
-              <a:ext uri="{FF2B5EF4-FFF2-40B4-BE49-F238E27FC236}">
-                <a16:creationId xmlns:a16="http://schemas.microsoft.com/office/drawing/2014/main" id="{2BD6D79E-3784-39A1-5BE0-598EDD61CF3D}"/>
-              </a:ext>
-            </a:extLst>
-          </p:cNvPr>
-          <p:cNvSpPr>
-            <a:spLocks noGrp="1"/>
-          </p:cNvSpPr>
-          <p:nvPr>
-            <p:ph type="body" sz="quarter" idx="10" hasCustomPrompt="1"/>
-          </p:nvPr>
-        </p:nvSpPr>
-        <p:spPr>
-          <a:xfrm>
-            <a:off x="27015" y="5476869"/>
-            <a:ext cx="2051342" cy="438403"/>
-          </a:xfrm>
-          <a:prstGeom prst="rect">
-            <a:avLst/>
-          </a:prstGeom>
-        </p:spPr>
-        <p:txBody>
-          <a:bodyPr lIns="0" tIns="0" rIns="0" bIns="0"/>
-          <a:lstStyle>
-            <a:lvl1pPr marL="0" indent="0" algn="r">
-              <a:buNone/>
-              <a:defRPr sz="1600"/>
-            </a:lvl1pPr>
-          </a:lstStyle>
-          <a:p>
-            <a:pPr lvl="0"/>
-            <a:r>
-              <a:rPr lang="en-AU" dirty="0"/>
-              <a:t>Median Door to Device time was X min</a:t>
-            </a:r>
-          </a:p>
-        </p:txBody>
-      </p:sp>
       <p:grpSp>
         <p:nvGrpSpPr>
-          <p:cNvPr id="10" name="ph_door_to_reperfusion">
+          <p:cNvPr id="10" name="grp_NCR2">
             <a:extLst>
               <a:ext uri="{FF2B5EF4-FFF2-40B4-BE49-F238E27FC236}">
                 <a16:creationId xmlns:a16="http://schemas.microsoft.com/office/drawing/2014/main" id="{A1CBE341-2177-8914-E409-ABE64EB1445D}"/>
@@ -2498,7 +2498,7 @@
         </p:grpSpPr>
         <p:sp>
           <p:nvSpPr>
-            <p:cNvPr id="17" name="shp_urg">
+            <p:cNvPr id="17" name="shp_NCR2">
               <a:extLst>
                 <a:ext uri="{FF2B5EF4-FFF2-40B4-BE49-F238E27FC236}">
                   <a16:creationId xmlns:a16="http://schemas.microsoft.com/office/drawing/2014/main" id="{E153B05D-1487-8051-2ADA-5CCDC9A62160}"/>
@@ -2554,7 +2554,7 @@
         </p:sp>
         <p:pic>
           <p:nvPicPr>
-            <p:cNvPr id="30" name="pic_urgency">
+            <p:cNvPr id="30" name="pic_NCR2">
               <a:extLst>
                 <a:ext uri="{FF2B5EF4-FFF2-40B4-BE49-F238E27FC236}">
                   <a16:creationId xmlns:a16="http://schemas.microsoft.com/office/drawing/2014/main" id="{11D4B853-1ADD-0145-DAD2-521BC0A43308}"/>
@@ -2591,7 +2591,7 @@
       </p:grpSp>
       <p:sp>
         <p:nvSpPr>
-          <p:cNvPr id="40" name="ph_pci">
+          <p:cNvPr id="40" name="ph_VOL_PCI_desc">
             <a:extLst>
               <a:ext uri="{FF2B5EF4-FFF2-40B4-BE49-F238E27FC236}">
                 <a16:creationId xmlns:a16="http://schemas.microsoft.com/office/drawing/2014/main" id="{3AAC2047-1448-EBFC-6433-602F17048C37}"/>
@@ -2637,7 +2637,7 @@
       </p:sp>
       <p:sp>
         <p:nvSpPr>
-          <p:cNvPr id="51" name="ph_pci_count">
+          <p:cNvPr id="51" name="ph_VOL_PCI_value">
             <a:extLst>
               <a:ext uri="{FF2B5EF4-FFF2-40B4-BE49-F238E27FC236}">
                 <a16:creationId xmlns:a16="http://schemas.microsoft.com/office/drawing/2014/main" id="{BD10F3DD-814C-87B1-F3BC-B6770621C718}"/>
@@ -2712,7 +2712,7 @@
       </p:sp>
       <p:grpSp>
         <p:nvGrpSpPr>
-          <p:cNvPr id="9" name="pci">
+          <p:cNvPr id="9" name="grp_VOL_PCI">
             <a:extLst>
               <a:ext uri="{FF2B5EF4-FFF2-40B4-BE49-F238E27FC236}">
                 <a16:creationId xmlns:a16="http://schemas.microsoft.com/office/drawing/2014/main" id="{36EB1C80-C89F-6BA4-E43C-FD80AE153602}"/>
@@ -2732,7 +2732,7 @@
         </p:grpSpPr>
         <p:sp>
           <p:nvSpPr>
-            <p:cNvPr id="20" name="shp_pci">
+            <p:cNvPr id="20" name="shp_VOL_PCI">
               <a:extLst>
                 <a:ext uri="{FF2B5EF4-FFF2-40B4-BE49-F238E27FC236}">
                   <a16:creationId xmlns:a16="http://schemas.microsoft.com/office/drawing/2014/main" id="{4AAEA4BB-C109-28FA-B6A2-6EF5B68D1217}"/>
@@ -2788,7 +2788,7 @@
         </p:sp>
         <p:pic>
           <p:nvPicPr>
-            <p:cNvPr id="14" name="pic_pci">
+            <p:cNvPr id="14" name="pic_VOL_PCI">
               <a:extLst>
                 <a:ext uri="{FF2B5EF4-FFF2-40B4-BE49-F238E27FC236}">
                   <a16:creationId xmlns:a16="http://schemas.microsoft.com/office/drawing/2014/main" id="{E8591D62-F0EC-DF4B-55A0-003CBCE760CC}"/>
@@ -3246,7 +3246,7 @@
                 <a:solidFill>
                   <a:srgbClr val="19456A"/>
                 </a:solidFill>
-                <a:latin typeface="Segoe UI" panose="020B0502040204020203" pitchFamily="34" charset="0"/>
+                <a:latin typeface="+mn-lt"/>
                 <a:cs typeface="Segoe UI" panose="020B0502040204020203" pitchFamily="34" charset="0"/>
               </a:rPr>
               <a:t>CRoWA</a:t>
@@ -6518,7 +6518,7 @@
         <p:spPr>
           <a:xfrm>
             <a:off x="2246062" y="728786"/>
-            <a:ext cx="2360140" cy="769441"/>
+            <a:ext cx="2360140" cy="707886"/>
           </a:xfrm>
           <a:prstGeom prst="rect">
             <a:avLst/>
@@ -6533,8 +6533,8 @@
           <a:p>
             <a:pPr algn="ctr"/>
             <a:r>
-              <a:rPr lang="en-AU" sz="2200" b="1" dirty="0">
-                <a:latin typeface="Calibri" panose="020F0502020204030204" pitchFamily="34" charset="0"/>
+              <a:rPr lang="en-AU" sz="2000" b="1" dirty="0">
+                <a:latin typeface="+mn-lt"/>
                 <a:ea typeface="Calibri" panose="020F0502020204030204" pitchFamily="34" charset="0"/>
                 <a:cs typeface="Calibri" panose="020F0502020204030204" pitchFamily="34" charset="0"/>
               </a:rPr>

</xml_diff>

<commit_message>
Minor poster fixes and namespaces fixes
</commit_message>
<xml_diff>
--- a/pci_poster/poster_template.pptx
+++ b/pci_poster/poster_template.pptx
@@ -732,7 +732,7 @@
           <a:p>
             <a:fld id="{71C53CA5-41C7-4923-8C6F-B3E91010339F}" type="datetimeFigureOut">
               <a:rPr lang="en-AU" smtClean="0"/>
-              <a:t>16/10/2026</a:t>
+              <a:t>21/10/2026</a:t>
             </a:fld>
             <a:endParaRPr lang="en-AU"/>
           </a:p>
@@ -909,7 +909,7 @@
           <a:p>
             <a:fld id="{C000ED89-5811-46A2-AFCA-7C8C83CE9906}" type="datetimeFigureOut">
               <a:rPr lang="en-AU" smtClean="0"/>
-              <a:t>16/10/2026</a:t>
+              <a:t>21/10/2026</a:t>
             </a:fld>
             <a:endParaRPr lang="en-AU"/>
           </a:p>
@@ -2344,8 +2344,8 @@
         </p:nvSpPr>
         <p:spPr>
           <a:xfrm>
-            <a:off x="115329" y="4990048"/>
-            <a:ext cx="1231345" cy="504000"/>
+            <a:off x="542535" y="4990048"/>
+            <a:ext cx="804139" cy="504000"/>
           </a:xfrm>
           <a:prstGeom prst="rect">
             <a:avLst/>
@@ -2851,7 +2851,7 @@
         <p:spPr>
           <a:xfrm>
             <a:off x="216695" y="1562072"/>
-            <a:ext cx="4594397" cy="606792"/>
+            <a:ext cx="4958583" cy="606792"/>
           </a:xfrm>
           <a:prstGeom prst="roundRect">
             <a:avLst/>

</xml_diff>